<commit_message>
Realign project to hypothesis generation (gap → new hypothesis proposal)
Project goal shifts from Q&A literature synthesis → discovering rationale-backed
new research hypotheses. Pipeline: 자료파악 → gap발견 → 가설생성(다수) → 평가·우선순위 → 제안.

- timetable: Day 3 오후2 framing, Day 4 scope+sessions (가설 생성·평가), Day 5 (가설 제안서)
- slides: Day 3 오후2 project/pipeline/lab/takeaways; Day 4 all 3 sessions; Day 5 buffer+제안서
- examples/research-agent: CLAUDE.md (hypothesis rules), README, plan/report templates, corpus index, research-prompts → gap/hypothesis flow
- script.md: Day 3 pipeline/lab + Day 4 가설평가 + Day 5 제안서 narration; +Day 3 오전, Day 2 오전 lecture scripts (46 authored)

Co-Authored-By: Claude Opus 4.8 <noreply@anthropic.com>
</commit_message>
<xml_diff>
--- a/slides/day3.pptx
+++ b/slides/day3.pptx
@@ -10808,7 +10808,7 @@
                 <a:ea typeface="NanumGothic"/>
                 <a:cs typeface="NanumGothic"/>
               </a:rPr>
-              <a:t>리서치 에이전트 파이프라인</a:t>
+              <a:t>가설 생성 파이프라인</a:t>
             </a:r>
           </a:p>
         </p:txBody>
@@ -17186,7 +17186,7 @@
                 <a:ea typeface="NanumGothic"/>
                 <a:cs typeface="NanumGothic"/>
               </a:rPr>
-              <a:t>팀별 '풀 리서치 에이전트' 구현 (자기 관심 주제)</a:t>
+              <a:t>자기 관심 분야에서 'rationale 갖춘 새 가설'을 발견·제안하는 에이전트</a:t>
             </a:r>
           </a:p>
         </p:txBody>
@@ -17324,7 +17324,7 @@
                 <a:ea typeface="NanumGothic"/>
                 <a:cs typeface="NanumGothic"/>
               </a:rPr>
-              <a:t>corpus 기반 · 질문→검색→검증→종합→보고 · Day 4 안에 완주</a:t>
+              <a:t>corpus 기반 · 자료파악→gap발견→가설생성→평가·제안 · Day 4 안에 완주</a:t>
             </a:r>
           </a:p>
         </p:txBody>
@@ -17462,7 +17462,7 @@
                 <a:ea typeface="NanumGothic"/>
                 <a:cs typeface="NanumGothic"/>
               </a:rPr>
-              <a:t>핵심 질문에 답하는 1~2장 인용 보고서</a:t>
+              <a:t>rationale 갖춘 새 연구 가설 제안서 (Q&amp;A 보고서 아님)</a:t>
             </a:r>
           </a:p>
         </p:txBody>
@@ -17662,7 +17662,7 @@
                 <a:ea typeface="NanumSquare"/>
                 <a:cs typeface="NanumSquare"/>
               </a:rPr>
-              <a:t>리서치 에이전트 파이프라인 (만들 것)</a:t>
+              <a:t>가설 생성 파이프라인 (만들 것)</a:t>
             </a:r>
           </a:p>
         </p:txBody>
@@ -17984,7 +17984,7 @@
                 <a:ea typeface="NanumGothic"/>
                 <a:cs typeface="NanumGothic"/>
               </a:rPr>
-              <a:t>질문</a:t>
+              <a:t>주제 설정</a:t>
             </a:r>
           </a:p>
         </p:txBody>
@@ -18031,7 +18031,7 @@
                 <a:ea typeface="NanumGothic"/>
                 <a:cs typeface="NanumGothic"/>
               </a:rPr>
-              <a:t>핵심 질문·분해</a:t>
+              <a:t>관심 분야·발견 목표</a:t>
             </a:r>
           </a:p>
         </p:txBody>
@@ -18262,7 +18262,7 @@
                 <a:ea typeface="NanumGothic"/>
                 <a:cs typeface="NanumGothic"/>
               </a:rPr>
-              <a:t>검색</a:t>
+              <a:t>자료 파악</a:t>
             </a:r>
           </a:p>
         </p:txBody>
@@ -18309,7 +18309,7 @@
                 <a:ea typeface="NanumGothic"/>
                 <a:cs typeface="NanumGothic"/>
               </a:rPr>
-              <a:t>로컬 corpus</a:t>
+              <a:t>로컬 corpus 정리</a:t>
             </a:r>
           </a:p>
         </p:txBody>
@@ -18540,7 +18540,7 @@
                 <a:ea typeface="NanumGothic"/>
                 <a:cs typeface="NanumGothic"/>
               </a:rPr>
-              <a:t>검증</a:t>
+              <a:t>gap 발견</a:t>
             </a:r>
           </a:p>
         </p:txBody>
@@ -18587,7 +18587,7 @@
                 <a:ea typeface="NanumGothic"/>
                 <a:cs typeface="NanumGothic"/>
               </a:rPr>
-              <a:t>출처·교차확인</a:t>
+              <a:t>모순·공백·미검증</a:t>
             </a:r>
           </a:p>
         </p:txBody>
@@ -18818,7 +18818,7 @@
                 <a:ea typeface="NanumGothic"/>
                 <a:cs typeface="NanumGothic"/>
               </a:rPr>
-              <a:t>종합</a:t>
+              <a:t>가설 생성</a:t>
             </a:r>
           </a:p>
         </p:txBody>
@@ -18865,7 +18865,7 @@
                 <a:ea typeface="NanumGothic"/>
                 <a:cs typeface="NanumGothic"/>
               </a:rPr>
-              <a:t>근거→답</a:t>
+              <a:t>gap·조합 기반 다수</a:t>
             </a:r>
           </a:p>
         </p:txBody>
@@ -19096,7 +19096,7 @@
                 <a:ea typeface="NanumGothic"/>
                 <a:cs typeface="NanumGothic"/>
               </a:rPr>
-              <a:t>보고</a:t>
+              <a:t>평가·제안</a:t>
             </a:r>
           </a:p>
         </p:txBody>
@@ -19143,7 +19143,7 @@
                 <a:ea typeface="NanumGothic"/>
                 <a:cs typeface="NanumGothic"/>
               </a:rPr>
-              <a:t>인용 보고서</a:t>
+              <a:t>rationale·우선순위</a:t>
             </a:r>
           </a:p>
         </p:txBody>
@@ -19247,7 +19247,7 @@
                 <a:ea typeface="NanumGothic"/>
                 <a:cs typeface="NanumGothic"/>
               </a:rPr>
-              <a:t>Day 4에 이 흐름을 직접 구현·실행한다</a:t>
+              <a:t>agentic 5단계와 동일 — Day 4에 직접 구현·실행한다</a:t>
             </a:r>
           </a:p>
         </p:txBody>
@@ -19447,7 +19447,7 @@
                 <a:ea typeface="NanumSquare"/>
                 <a:cs typeface="NanumSquare"/>
               </a:rPr>
-              <a:t>팀 구성 &amp; 주제·기획</a:t>
+              <a:t>팀 구성 &amp; 분야·기획</a:t>
             </a:r>
           </a:p>
         </p:txBody>
@@ -19954,7 +19954,7 @@
                 <a:ea typeface="NanumGothic"/>
                 <a:cs typeface="NanumGothic"/>
               </a:rPr>
-              <a:t>관심 주제 확정 + 핵심 질문</a:t>
+              <a:t>관심 분야 + 발견 목표(무엇을 제안하고 싶나)</a:t>
             </a:r>
           </a:p>
         </p:txBody>
@@ -20369,7 +20369,7 @@
                 <a:cs typeface="NanumGothic"/>
               </a:rPr>
               <a:t>팀 기획서
-(주제 · 핵심질문 · corpus · 산출물 · 스코프)
+(분야 · 발견 목표 · corpus · 산출물=가설 제안 · 스코프)
 예: 신약/바이오 리서치 등
 템플릿: examples/research-agent/research-plan-template.md</a:t>
             </a:r>
@@ -20847,7 +20847,7 @@
                 <a:ea typeface="NanumGothic"/>
                 <a:cs typeface="NanumGothic"/>
               </a:rPr>
-              <a:t>리서치 = 분야→문헌→가설→검증의 반복 루프, agent로 각 단계를 도울 수 있다</a:t>
+              <a:t>우리 목표 = corpus의 gap에서 'rationale 갖춘 새 가설'을 발견·제안 (질문 답변이 아님)</a:t>
             </a:r>
           </a:p>
         </p:txBody>
@@ -21029,7 +21029,7 @@
                 <a:ea typeface="NanumGothic"/>
                 <a:cs typeface="NanumGothic"/>
               </a:rPr>
-              <a:t>팀·주제·핵심 질문·corpus 계획 확정 — Day 4에 풀 에이전트(스코프) 구현</a:t>
+              <a:t>팀·분야·발견 목표·corpus 계획 확정 — Day 4에 가설 생성 에이전트 구현</a:t>
             </a:r>
           </a:p>
         </p:txBody>
@@ -21169,7 +21169,7 @@
                 <a:ea typeface="NanumGothic"/>
                 <a:cs typeface="NanumGothic"/>
               </a:rPr>
-              <a:t>확정한 주제로 corpus 기반 리서치 에이전트를 Day 4 3세션 안에 구현·실행·분석합니다.</a:t>
+              <a:t>확정한 분야로 corpus 기반 가설 생성 에이전트를 Day 4 3세션 안에 구현·실행해 새 가설을 제안합니다.</a:t>
             </a:r>
           </a:p>
         </p:txBody>

</xml_diff>

<commit_message>
Replace casual wording with professional terms
깔때기→단계적 선별, 함정→유의점, 생포→직접 확인, 빚는다→형성된다.
Recorded preference: no colloquial/cutesy wording.

Co-Authored-By: Claude Opus 4.8 <noreply@anthropic.com>
</commit_message>
<xml_diff>
--- a/slides/day3.pptx
+++ b/slides/day3.pptx
@@ -10810,7 +10810,7 @@
                 <a:ea typeface="NanumGothic"/>
                 <a:cs typeface="NanumGothic"/>
               </a:rPr>
-              <a:t>권고·funnel·신약 주의</a:t>
+              <a:t>권고·단계적 선별·신약 유의점</a:t>
             </a:r>
           </a:p>
         </p:txBody>
@@ -18351,7 +18351,7 @@
                 <a:ea typeface="NanumGothic"/>
                 <a:cs typeface="NanumGothic"/>
               </a:rPr>
-              <a:t>funnel</a:t>
+              <a:t>선별 절차</a:t>
             </a:r>
           </a:p>
         </p:txBody>
@@ -18398,7 +18398,7 @@
                 <a:ea typeface="NanumSquare"/>
                 <a:cs typeface="NanumSquare"/>
               </a:rPr>
-              <a:t>생성에서 검증까지 — 깔때기</a:t>
+              <a:t>생성에서 검증까지 — 단계적 선별</a:t>
             </a:r>
           </a:p>
         </p:txBody>
@@ -18951,7 +18951,7 @@
                 <a:ea typeface="NanumGothic"/>
                 <a:cs typeface="NanumGothic"/>
               </a:rPr>
-              <a:t>최소 prune</a:t>
+              <a:t>최소 정리</a:t>
             </a:r>
           </a:p>
         </p:txBody>
@@ -19229,7 +19229,7 @@
                 <a:ea typeface="NanumGothic"/>
                 <a:cs typeface="NanumGothic"/>
               </a:rPr>
-              <a:t>싼 경험적 스크린</a:t>
+              <a:t>싼 경험적 선별</a:t>
             </a:r>
           </a:p>
         </p:txBody>
@@ -19276,7 +19276,7 @@
                 <a:ea typeface="NanumGothic"/>
                 <a:cs typeface="NanumGothic"/>
               </a:rPr>
-              <a:t>실제 선별</a:t>
+              <a:t>실측으로 추리기</a:t>
             </a:r>
           </a:p>
         </p:txBody>
@@ -19658,7 +19658,7 @@
                 <a:ea typeface="NanumGothic"/>
                 <a:cs typeface="NanumGothic"/>
               </a:rPr>
-              <a:t>선별은 LLM의 취향이 아니라 싼 실측으로 한다 — winner를 미리 고르지 않는다.</a:t>
+              <a:t>선별은 모델의 판단이 아니라 비용이 낮은 실측으로 수행하며, 유망 가설을 미리 단정하지 않는다.</a:t>
             </a:r>
           </a:p>
         </p:txBody>
@@ -19869,7 +19869,7 @@
                 <a:ea typeface="NanumGothic"/>
                 <a:cs typeface="NanumGothic"/>
               </a:rPr>
-              <a:t>주의</a:t>
+              <a:t>유의점</a:t>
             </a:r>
           </a:p>
         </p:txBody>
@@ -19916,7 +19916,7 @@
                 <a:ea typeface="NanumSquare"/>
                 <a:cs typeface="NanumSquare"/>
               </a:rPr>
-              <a:t>함정 — 특히 신약 분야에서</a:t>
+              <a:t>유의점 — 특히 신약 분야에서</a:t>
             </a:r>
           </a:p>
         </p:txBody>

</xml_diff>